<commit_message>
Fix table header contrast and sharpen chart axis labels.
Wire theme table.header_bg into native PPTX tables, render plots at 3× DPI without stretching, and keep category tick labels intact.

Co-authored-by: Cursor <cursoragent@cursor.com>
</commit_message>
<xml_diff>
--- a/examples/demo.pptx
+++ b/examples/demo.pptx
@@ -7764,7 +7764,7 @@
       </p:sp>
       <p:pic>
         <p:nvPicPr>
-          <p:cNvPr id="14" name="Image 1" descr="/Users/dpadmana/projects/ppt-gen/assets/plots/regions-85083c9a3d.png">    </p:cNvPr>
+          <p:cNvPr id="14" name="Image 1" descr="/Users/dpadmana/projects/ppt-gen/assets/plots/regions-fc949fbe1b.png">    </p:cNvPr>
           <p:cNvPicPr>
             <a:picLocks noChangeAspect="1"/>
           </p:cNvPicPr>
@@ -8321,7 +8321,7 @@
                       <a:tailEnd type="none" w="med" len="med"/>
                     </a:lnB>
                     <a:solidFill>
-                      <a:srgbClr val="EAEAEA"/>
+                      <a:srgbClr val="4E79A7"/>
                     </a:solidFill>
                   </a:tcPr>
                 </a:tc>
@@ -8389,7 +8389,7 @@
                       <a:tailEnd type="none" w="med" len="med"/>
                     </a:lnB>
                     <a:solidFill>
-                      <a:srgbClr val="EAEAEA"/>
+                      <a:srgbClr val="4E79A7"/>
                     </a:solidFill>
                   </a:tcPr>
                 </a:tc>
@@ -8457,7 +8457,7 @@
                       <a:tailEnd type="none" w="med" len="med"/>
                     </a:lnB>
                     <a:solidFill>
-                      <a:srgbClr val="EAEAEA"/>
+                      <a:srgbClr val="4E79A7"/>
                     </a:solidFill>
                   </a:tcPr>
                 </a:tc>
@@ -13101,7 +13101,7 @@
       </p:sp>
       <p:pic>
         <p:nvPicPr>
-          <p:cNvPr id="7" name="Image 1" descr="/Users/dpadmana/projects/ppt-gen/assets/plots/quarterly-a5d5f8a619.png">    </p:cNvPr>
+          <p:cNvPr id="7" name="Image 1" descr="/Users/dpadmana/projects/ppt-gen/assets/plots/quarterly-46e42b95c2.png">    </p:cNvPr>
           <p:cNvPicPr>
             <a:picLocks noChangeAspect="1"/>
           </p:cNvPicPr>
@@ -18186,7 +18186,7 @@
       </p:sp>
       <p:pic>
         <p:nvPicPr>
-          <p:cNvPr id="7" name="Image 1" descr="/Users/dpadmana/projects/ppt-gen/assets/plots/channels-99f91be3d7.png">    </p:cNvPr>
+          <p:cNvPr id="7" name="Image 1" descr="/Users/dpadmana/projects/ppt-gen/assets/plots/channels-753319639b.png">    </p:cNvPr>
           <p:cNvPicPr>
             <a:picLocks noChangeAspect="1"/>
           </p:cNvPicPr>
@@ -19189,11 +19189,11 @@
         <p:spPr>
           <a:xfrm>
             <a:off x="400050" y="1123950"/>
-            <a:ext cx="11010900" cy="2514600"/>
+            <a:ext cx="11010900" cy="2362200"/>
           </a:xfrm>
           <a:prstGeom prst="roundRect">
             <a:avLst>
-              <a:gd name="adj" fmla="val 3636"/>
+              <a:gd name="adj" fmla="val 3871"/>
             </a:avLst>
           </a:prstGeom>
           <a:solidFill>
@@ -19222,17 +19222,17 @@
           </p:nvPr>
         </p:nvGraphicFramePr>
         <p:xfrm>
-          <a:off x="476250" y="1162050"/>
-          <a:ext cx="10858500" cy="914400"/>
+          <a:off x="438150" y="1162050"/>
+          <a:ext cx="10934700" cy="914400"/>
         </p:xfrm>
         <a:graphic>
           <a:graphicData uri="http://schemas.openxmlformats.org/drawingml/2006/table">
             <a:tbl>
               <a:tblPr/>
               <a:tblGrid>
-                <a:gridCol w="4126230"/>
-                <a:gridCol w="3366135"/>
-                <a:gridCol w="3366135"/>
+                <a:gridCol w="3644900"/>
+                <a:gridCol w="3644900"/>
+                <a:gridCol w="3644900"/>
               </a:tblGrid>
               <a:tr h="457200">
                 <a:tc>
@@ -19244,7 +19244,7 @@
                         <a:buNone/>
                       </a:pPr>
                       <a:r>
-                        <a:rPr lang="en-US" sz="1600" b="1" dirty="0">
+                        <a:rPr lang="en-US" sz="1500" b="1" dirty="0">
                           <a:solidFill>
                             <a:srgbClr val="FFFFFF"/>
                           </a:solidFill>
@@ -19254,7 +19254,7 @@
                         </a:rPr>
                         <a:t>region</a:t>
                       </a:r>
-                      <a:endParaRPr lang="en-US" sz="1600" dirty="0">
+                      <a:endParaRPr lang="en-US" sz="1500" dirty="0">
                         <a:latin typeface="Helvetica Neue" charset="0"/>
                         <a:ea typeface="Helvetica Neue" charset="0"/>
                         <a:cs typeface="Helvetica Neue" charset="0"/>
@@ -19299,7 +19299,7 @@
                       <a:tailEnd type="none" w="med" len="med"/>
                     </a:lnB>
                     <a:solidFill>
-                      <a:srgbClr val="EAEAEA"/>
+                      <a:srgbClr val="4E79A7"/>
                     </a:solidFill>
                   </a:tcPr>
                 </a:tc>
@@ -19312,7 +19312,7 @@
                         <a:buNone/>
                       </a:pPr>
                       <a:r>
-                        <a:rPr lang="en-US" sz="1600" b="1" dirty="0">
+                        <a:rPr lang="en-US" sz="1500" b="1" dirty="0">
                           <a:solidFill>
                             <a:srgbClr val="FFFFFF"/>
                           </a:solidFill>
@@ -19322,7 +19322,7 @@
                         </a:rPr>
                         <a:t>revenue_m</a:t>
                       </a:r>
-                      <a:endParaRPr lang="en-US" sz="1600" dirty="0">
+                      <a:endParaRPr lang="en-US" sz="1500" dirty="0">
                         <a:latin typeface="Helvetica Neue" charset="0"/>
                         <a:ea typeface="Helvetica Neue" charset="0"/>
                         <a:cs typeface="Helvetica Neue" charset="0"/>
@@ -19367,7 +19367,7 @@
                       <a:tailEnd type="none" w="med" len="med"/>
                     </a:lnB>
                     <a:solidFill>
-                      <a:srgbClr val="EAEAEA"/>
+                      <a:srgbClr val="4E79A7"/>
                     </a:solidFill>
                   </a:tcPr>
                 </a:tc>
@@ -19380,7 +19380,7 @@
                         <a:buNone/>
                       </a:pPr>
                       <a:r>
-                        <a:rPr lang="en-US" sz="1600" b="1" dirty="0">
+                        <a:rPr lang="en-US" sz="1500" b="1" dirty="0">
                           <a:solidFill>
                             <a:srgbClr val="FFFFFF"/>
                           </a:solidFill>
@@ -19390,7 +19390,7 @@
                         </a:rPr>
                         <a:t>growth_pct</a:t>
                       </a:r>
-                      <a:endParaRPr lang="en-US" sz="1600" dirty="0">
+                      <a:endParaRPr lang="en-US" sz="1500" dirty="0">
                         <a:latin typeface="Helvetica Neue" charset="0"/>
                         <a:ea typeface="Helvetica Neue" charset="0"/>
                         <a:cs typeface="Helvetica Neue" charset="0"/>
@@ -19435,7 +19435,7 @@
                       <a:tailEnd type="none" w="med" len="med"/>
                     </a:lnB>
                     <a:solidFill>
-                      <a:srgbClr val="EAEAEA"/>
+                      <a:srgbClr val="4E79A7"/>
                     </a:solidFill>
                   </a:tcPr>
                 </a:tc>
@@ -19450,7 +19450,7 @@
                         <a:buNone/>
                       </a:pPr>
                       <a:r>
-                        <a:rPr lang="en-US" sz="1600" b="1" dirty="0">
+                        <a:rPr lang="en-US" sz="1500" b="1" dirty="0">
                           <a:solidFill>
                             <a:srgbClr val="EAEAEA"/>
                           </a:solidFill>
@@ -19460,7 +19460,7 @@
                         </a:rPr>
                         <a:t>North America</a:t>
                       </a:r>
-                      <a:endParaRPr lang="en-US" sz="1600" dirty="0">
+                      <a:endParaRPr lang="en-US" sz="1500" dirty="0">
                         <a:latin typeface="Helvetica Neue" charset="0"/>
                         <a:ea typeface="Helvetica Neue" charset="0"/>
                         <a:cs typeface="Helvetica Neue" charset="0"/>
@@ -19518,7 +19518,7 @@
                         <a:buNone/>
                       </a:pPr>
                       <a:r>
-                        <a:rPr lang="en-US" sz="1600" dirty="0">
+                        <a:rPr lang="en-US" sz="1500" dirty="0">
                           <a:solidFill>
                             <a:srgbClr val="EAEAEA"/>
                           </a:solidFill>
@@ -19528,7 +19528,7 @@
                         </a:rPr>
                         <a:t>12.4</a:t>
                       </a:r>
-                      <a:endParaRPr lang="en-US" sz="1600" dirty="0">
+                      <a:endParaRPr lang="en-US" sz="1500" dirty="0">
                         <a:latin typeface="Helvetica Neue" charset="0"/>
                         <a:ea typeface="Helvetica Neue" charset="0"/>
                         <a:cs typeface="Helvetica Neue" charset="0"/>
@@ -19586,7 +19586,7 @@
                         <a:buNone/>
                       </a:pPr>
                       <a:r>
-                        <a:rPr lang="en-US" sz="1600" dirty="0">
+                        <a:rPr lang="en-US" sz="1500" dirty="0">
                           <a:solidFill>
                             <a:srgbClr val="EAEAEA"/>
                           </a:solidFill>
@@ -19596,7 +19596,7 @@
                         </a:rPr>
                         <a:t>11.2</a:t>
                       </a:r>
-                      <a:endParaRPr lang="en-US" sz="1600" dirty="0">
+                      <a:endParaRPr lang="en-US" sz="1500" dirty="0">
                         <a:latin typeface="Helvetica Neue" charset="0"/>
                         <a:ea typeface="Helvetica Neue" charset="0"/>
                         <a:cs typeface="Helvetica Neue" charset="0"/>
@@ -19656,7 +19656,7 @@
                         <a:buNone/>
                       </a:pPr>
                       <a:r>
-                        <a:rPr lang="en-US" sz="1600" b="1" dirty="0">
+                        <a:rPr lang="en-US" sz="1500" b="1" dirty="0">
                           <a:solidFill>
                             <a:srgbClr val="EAEAEA"/>
                           </a:solidFill>
@@ -19666,7 +19666,7 @@
                         </a:rPr>
                         <a:t>Europe</a:t>
                       </a:r>
-                      <a:endParaRPr lang="en-US" sz="1600" dirty="0">
+                      <a:endParaRPr lang="en-US" sz="1500" dirty="0">
                         <a:latin typeface="Helvetica Neue" charset="0"/>
                         <a:ea typeface="Helvetica Neue" charset="0"/>
                         <a:cs typeface="Helvetica Neue" charset="0"/>
@@ -19724,7 +19724,7 @@
                         <a:buNone/>
                       </a:pPr>
                       <a:r>
-                        <a:rPr lang="en-US" sz="1600" dirty="0">
+                        <a:rPr lang="en-US" sz="1500" dirty="0">
                           <a:solidFill>
                             <a:srgbClr val="EAEAEA"/>
                           </a:solidFill>
@@ -19734,7 +19734,7 @@
                         </a:rPr>
                         <a:t>8.7</a:t>
                       </a:r>
-                      <a:endParaRPr lang="en-US" sz="1600" dirty="0">
+                      <a:endParaRPr lang="en-US" sz="1500" dirty="0">
                         <a:latin typeface="Helvetica Neue" charset="0"/>
                         <a:ea typeface="Helvetica Neue" charset="0"/>
                         <a:cs typeface="Helvetica Neue" charset="0"/>
@@ -19792,7 +19792,7 @@
                         <a:buNone/>
                       </a:pPr>
                       <a:r>
-                        <a:rPr lang="en-US" sz="1600" dirty="0">
+                        <a:rPr lang="en-US" sz="1500" dirty="0">
                           <a:solidFill>
                             <a:srgbClr val="EAEAEA"/>
                           </a:solidFill>
@@ -19802,7 +19802,7 @@
                         </a:rPr>
                         <a:t>9.5</a:t>
                       </a:r>
-                      <a:endParaRPr lang="en-US" sz="1600" dirty="0">
+                      <a:endParaRPr lang="en-US" sz="1500" dirty="0">
                         <a:latin typeface="Helvetica Neue" charset="0"/>
                         <a:ea typeface="Helvetica Neue" charset="0"/>
                         <a:cs typeface="Helvetica Neue" charset="0"/>
@@ -19862,7 +19862,7 @@
                         <a:buNone/>
                       </a:pPr>
                       <a:r>
-                        <a:rPr lang="en-US" sz="1600" b="1" dirty="0">
+                        <a:rPr lang="en-US" sz="1500" b="1" dirty="0">
                           <a:solidFill>
                             <a:srgbClr val="EAEAEA"/>
                           </a:solidFill>
@@ -19872,7 +19872,7 @@
                         </a:rPr>
                         <a:t>Asia Pacific</a:t>
                       </a:r>
-                      <a:endParaRPr lang="en-US" sz="1600" dirty="0">
+                      <a:endParaRPr lang="en-US" sz="1500" dirty="0">
                         <a:latin typeface="Helvetica Neue" charset="0"/>
                         <a:ea typeface="Helvetica Neue" charset="0"/>
                         <a:cs typeface="Helvetica Neue" charset="0"/>
@@ -19930,7 +19930,7 @@
                         <a:buNone/>
                       </a:pPr>
                       <a:r>
-                        <a:rPr lang="en-US" sz="1600" dirty="0">
+                        <a:rPr lang="en-US" sz="1500" dirty="0">
                           <a:solidFill>
                             <a:srgbClr val="EAEAEA"/>
                           </a:solidFill>
@@ -19940,7 +19940,7 @@
                         </a:rPr>
                         <a:t>6.1</a:t>
                       </a:r>
-                      <a:endParaRPr lang="en-US" sz="1600" dirty="0">
+                      <a:endParaRPr lang="en-US" sz="1500" dirty="0">
                         <a:latin typeface="Helvetica Neue" charset="0"/>
                         <a:ea typeface="Helvetica Neue" charset="0"/>
                         <a:cs typeface="Helvetica Neue" charset="0"/>
@@ -19998,7 +19998,7 @@
                         <a:buNone/>
                       </a:pPr>
                       <a:r>
-                        <a:rPr lang="en-US" sz="1600" dirty="0">
+                        <a:rPr lang="en-US" sz="1500" dirty="0">
                           <a:solidFill>
                             <a:srgbClr val="EAEAEA"/>
                           </a:solidFill>
@@ -20008,7 +20008,7 @@
                         </a:rPr>
                         <a:t>14.8</a:t>
                       </a:r>
-                      <a:endParaRPr lang="en-US" sz="1600" dirty="0">
+                      <a:endParaRPr lang="en-US" sz="1500" dirty="0">
                         <a:latin typeface="Helvetica Neue" charset="0"/>
                         <a:ea typeface="Helvetica Neue" charset="0"/>
                         <a:cs typeface="Helvetica Neue" charset="0"/>
@@ -20068,7 +20068,7 @@
                         <a:buNone/>
                       </a:pPr>
                       <a:r>
-                        <a:rPr lang="en-US" sz="1600" b="1" dirty="0">
+                        <a:rPr lang="en-US" sz="1500" b="1" dirty="0">
                           <a:solidFill>
                             <a:srgbClr val="EAEAEA"/>
                           </a:solidFill>
@@ -20078,7 +20078,7 @@
                         </a:rPr>
                         <a:t>Latin America</a:t>
                       </a:r>
-                      <a:endParaRPr lang="en-US" sz="1600" dirty="0">
+                      <a:endParaRPr lang="en-US" sz="1500" dirty="0">
                         <a:latin typeface="Helvetica Neue" charset="0"/>
                         <a:ea typeface="Helvetica Neue" charset="0"/>
                         <a:cs typeface="Helvetica Neue" charset="0"/>
@@ -20136,7 +20136,7 @@
                         <a:buNone/>
                       </a:pPr>
                       <a:r>
-                        <a:rPr lang="en-US" sz="1600" dirty="0">
+                        <a:rPr lang="en-US" sz="1500" dirty="0">
                           <a:solidFill>
                             <a:srgbClr val="EAEAEA"/>
                           </a:solidFill>
@@ -20146,7 +20146,7 @@
                         </a:rPr>
                         <a:t>2.3</a:t>
                       </a:r>
-                      <a:endParaRPr lang="en-US" sz="1600" dirty="0">
+                      <a:endParaRPr lang="en-US" sz="1500" dirty="0">
                         <a:latin typeface="Helvetica Neue" charset="0"/>
                         <a:ea typeface="Helvetica Neue" charset="0"/>
                         <a:cs typeface="Helvetica Neue" charset="0"/>
@@ -20204,7 +20204,7 @@
                         <a:buNone/>
                       </a:pPr>
                       <a:r>
-                        <a:rPr lang="en-US" sz="1600" dirty="0">
+                        <a:rPr lang="en-US" sz="1500" dirty="0">
                           <a:solidFill>
                             <a:srgbClr val="EAEAEA"/>
                           </a:solidFill>
@@ -20214,7 +20214,7 @@
                         </a:rPr>
                         <a:t>7.1</a:t>
                       </a:r>
-                      <a:endParaRPr lang="en-US" sz="1600" dirty="0">
+                      <a:endParaRPr lang="en-US" sz="1500" dirty="0">
                         <a:latin typeface="Helvetica Neue" charset="0"/>
                         <a:ea typeface="Helvetica Neue" charset="0"/>
                         <a:cs typeface="Helvetica Neue" charset="0"/>
@@ -22170,7 +22170,7 @@
       </p:sp>
       <p:pic>
         <p:nvPicPr>
-          <p:cNvPr id="7" name="Image 1" descr="/Users/dpadmana/projects/ppt-gen/assets/plots/regions-a1574b2a94.png">    </p:cNvPr>
+          <p:cNvPr id="7" name="Image 1" descr="/Users/dpadmana/projects/ppt-gen/assets/plots/regions-542e4be784.png">    </p:cNvPr>
           <p:cNvPicPr>
             <a:picLocks noChangeAspect="1"/>
           </p:cNvPicPr>
@@ -22419,11 +22419,11 @@
         <p:spPr>
           <a:xfrm>
             <a:off x="400050" y="1123950"/>
-            <a:ext cx="11010900" cy="3009900"/>
+            <a:ext cx="11010900" cy="2819400"/>
           </a:xfrm>
           <a:prstGeom prst="roundRect">
             <a:avLst>
-              <a:gd name="adj" fmla="val 3038"/>
+              <a:gd name="adj" fmla="val 3243"/>
             </a:avLst>
           </a:prstGeom>
           <a:solidFill>
@@ -22452,17 +22452,17 @@
           </p:nvPr>
         </p:nvGraphicFramePr>
         <p:xfrm>
-          <a:off x="476250" y="1162050"/>
-          <a:ext cx="10858500" cy="914400"/>
+          <a:off x="438150" y="1162050"/>
+          <a:ext cx="10934700" cy="914400"/>
         </p:xfrm>
         <a:graphic>
           <a:graphicData uri="http://schemas.openxmlformats.org/drawingml/2006/table">
             <a:tbl>
               <a:tblPr/>
               <a:tblGrid>
-                <a:gridCol w="4126230"/>
-                <a:gridCol w="3366135"/>
-                <a:gridCol w="3366135"/>
+                <a:gridCol w="3644900"/>
+                <a:gridCol w="3644900"/>
+                <a:gridCol w="3644900"/>
               </a:tblGrid>
               <a:tr h="457200">
                 <a:tc>
@@ -22474,7 +22474,7 @@
                         <a:buNone/>
                       </a:pPr>
                       <a:r>
-                        <a:rPr lang="en-US" sz="1600" b="1" dirty="0">
+                        <a:rPr lang="en-US" sz="1500" b="1" dirty="0">
                           <a:solidFill>
                             <a:srgbClr val="FFFFFF"/>
                           </a:solidFill>
@@ -22484,7 +22484,7 @@
                         </a:rPr>
                         <a:t>channel</a:t>
                       </a:r>
-                      <a:endParaRPr lang="en-US" sz="1600" dirty="0">
+                      <a:endParaRPr lang="en-US" sz="1500" dirty="0">
                         <a:latin typeface="Helvetica Neue" charset="0"/>
                         <a:ea typeface="Helvetica Neue" charset="0"/>
                         <a:cs typeface="Helvetica Neue" charset="0"/>
@@ -22529,7 +22529,7 @@
                       <a:tailEnd type="none" w="med" len="med"/>
                     </a:lnB>
                     <a:solidFill>
-                      <a:srgbClr val="EAEAEA"/>
+                      <a:srgbClr val="4E79A7"/>
                     </a:solidFill>
                   </a:tcPr>
                 </a:tc>
@@ -22542,7 +22542,7 @@
                         <a:buNone/>
                       </a:pPr>
                       <a:r>
-                        <a:rPr lang="en-US" sz="1600" b="1" dirty="0">
+                        <a:rPr lang="en-US" sz="1500" b="1" dirty="0">
                           <a:solidFill>
                             <a:srgbClr val="FFFFFF"/>
                           </a:solidFill>
@@ -22552,7 +22552,7 @@
                         </a:rPr>
                         <a:t>share_pct</a:t>
                       </a:r>
-                      <a:endParaRPr lang="en-US" sz="1600" dirty="0">
+                      <a:endParaRPr lang="en-US" sz="1500" dirty="0">
                         <a:latin typeface="Helvetica Neue" charset="0"/>
                         <a:ea typeface="Helvetica Neue" charset="0"/>
                         <a:cs typeface="Helvetica Neue" charset="0"/>
@@ -22597,7 +22597,7 @@
                       <a:tailEnd type="none" w="med" len="med"/>
                     </a:lnB>
                     <a:solidFill>
-                      <a:srgbClr val="EAEAEA"/>
+                      <a:srgbClr val="4E79A7"/>
                     </a:solidFill>
                   </a:tcPr>
                 </a:tc>
@@ -22610,7 +22610,7 @@
                         <a:buNone/>
                       </a:pPr>
                       <a:r>
-                        <a:rPr lang="en-US" sz="1600" b="1" dirty="0">
+                        <a:rPr lang="en-US" sz="1500" b="1" dirty="0">
                           <a:solidFill>
                             <a:srgbClr val="FFFFFF"/>
                           </a:solidFill>
@@ -22620,7 +22620,7 @@
                         </a:rPr>
                         <a:t>nps</a:t>
                       </a:r>
-                      <a:endParaRPr lang="en-US" sz="1600" dirty="0">
+                      <a:endParaRPr lang="en-US" sz="1500" dirty="0">
                         <a:latin typeface="Helvetica Neue" charset="0"/>
                         <a:ea typeface="Helvetica Neue" charset="0"/>
                         <a:cs typeface="Helvetica Neue" charset="0"/>
@@ -22665,7 +22665,7 @@
                       <a:tailEnd type="none" w="med" len="med"/>
                     </a:lnB>
                     <a:solidFill>
-                      <a:srgbClr val="EAEAEA"/>
+                      <a:srgbClr val="4E79A7"/>
                     </a:solidFill>
                   </a:tcPr>
                 </a:tc>
@@ -22680,7 +22680,7 @@
                         <a:buNone/>
                       </a:pPr>
                       <a:r>
-                        <a:rPr lang="en-US" sz="1600" b="1" dirty="0">
+                        <a:rPr lang="en-US" sz="1500" b="1" dirty="0">
                           <a:solidFill>
                             <a:srgbClr val="EAEAEA"/>
                           </a:solidFill>
@@ -22690,7 +22690,7 @@
                         </a:rPr>
                         <a:t>Web</a:t>
                       </a:r>
-                      <a:endParaRPr lang="en-US" sz="1600" dirty="0">
+                      <a:endParaRPr lang="en-US" sz="1500" dirty="0">
                         <a:latin typeface="Helvetica Neue" charset="0"/>
                         <a:ea typeface="Helvetica Neue" charset="0"/>
                         <a:cs typeface="Helvetica Neue" charset="0"/>
@@ -22748,7 +22748,7 @@
                         <a:buNone/>
                       </a:pPr>
                       <a:r>
-                        <a:rPr lang="en-US" sz="1600" dirty="0">
+                        <a:rPr lang="en-US" sz="1500" dirty="0">
                           <a:solidFill>
                             <a:srgbClr val="EAEAEA"/>
                           </a:solidFill>
@@ -22758,7 +22758,7 @@
                         </a:rPr>
                         <a:t>34</a:t>
                       </a:r>
-                      <a:endParaRPr lang="en-US" sz="1600" dirty="0">
+                      <a:endParaRPr lang="en-US" sz="1500" dirty="0">
                         <a:latin typeface="Helvetica Neue" charset="0"/>
                         <a:ea typeface="Helvetica Neue" charset="0"/>
                         <a:cs typeface="Helvetica Neue" charset="0"/>
@@ -22816,7 +22816,7 @@
                         <a:buNone/>
                       </a:pPr>
                       <a:r>
-                        <a:rPr lang="en-US" sz="1600" dirty="0">
+                        <a:rPr lang="en-US" sz="1500" dirty="0">
                           <a:solidFill>
                             <a:srgbClr val="EAEAEA"/>
                           </a:solidFill>
@@ -22826,7 +22826,7 @@
                         </a:rPr>
                         <a:t>42</a:t>
                       </a:r>
-                      <a:endParaRPr lang="en-US" sz="1600" dirty="0">
+                      <a:endParaRPr lang="en-US" sz="1500" dirty="0">
                         <a:latin typeface="Helvetica Neue" charset="0"/>
                         <a:ea typeface="Helvetica Neue" charset="0"/>
                         <a:cs typeface="Helvetica Neue" charset="0"/>
@@ -22886,7 +22886,7 @@
                         <a:buNone/>
                       </a:pPr>
                       <a:r>
-                        <a:rPr lang="en-US" sz="1600" b="1" dirty="0">
+                        <a:rPr lang="en-US" sz="1500" b="1" dirty="0">
                           <a:solidFill>
                             <a:srgbClr val="EAEAEA"/>
                           </a:solidFill>
@@ -22896,7 +22896,7 @@
                         </a:rPr>
                         <a:t>Mobile app</a:t>
                       </a:r>
-                      <a:endParaRPr lang="en-US" sz="1600" dirty="0">
+                      <a:endParaRPr lang="en-US" sz="1500" dirty="0">
                         <a:latin typeface="Helvetica Neue" charset="0"/>
                         <a:ea typeface="Helvetica Neue" charset="0"/>
                         <a:cs typeface="Helvetica Neue" charset="0"/>
@@ -22954,7 +22954,7 @@
                         <a:buNone/>
                       </a:pPr>
                       <a:r>
-                        <a:rPr lang="en-US" sz="1600" dirty="0">
+                        <a:rPr lang="en-US" sz="1500" dirty="0">
                           <a:solidFill>
                             <a:srgbClr val="EAEAEA"/>
                           </a:solidFill>
@@ -22964,7 +22964,7 @@
                         </a:rPr>
                         <a:t>28</a:t>
                       </a:r>
-                      <a:endParaRPr lang="en-US" sz="1600" dirty="0">
+                      <a:endParaRPr lang="en-US" sz="1500" dirty="0">
                         <a:latin typeface="Helvetica Neue" charset="0"/>
                         <a:ea typeface="Helvetica Neue" charset="0"/>
                         <a:cs typeface="Helvetica Neue" charset="0"/>
@@ -23022,7 +23022,7 @@
                         <a:buNone/>
                       </a:pPr>
                       <a:r>
-                        <a:rPr lang="en-US" sz="1600" dirty="0">
+                        <a:rPr lang="en-US" sz="1500" dirty="0">
                           <a:solidFill>
                             <a:srgbClr val="EAEAEA"/>
                           </a:solidFill>
@@ -23032,7 +23032,7 @@
                         </a:rPr>
                         <a:t>51</a:t>
                       </a:r>
-                      <a:endParaRPr lang="en-US" sz="1600" dirty="0">
+                      <a:endParaRPr lang="en-US" sz="1500" dirty="0">
                         <a:latin typeface="Helvetica Neue" charset="0"/>
                         <a:ea typeface="Helvetica Neue" charset="0"/>
                         <a:cs typeface="Helvetica Neue" charset="0"/>
@@ -23092,7 +23092,7 @@
                         <a:buNone/>
                       </a:pPr>
                       <a:r>
-                        <a:rPr lang="en-US" sz="1600" b="1" dirty="0">
+                        <a:rPr lang="en-US" sz="1500" b="1" dirty="0">
                           <a:solidFill>
                             <a:srgbClr val="EAEAEA"/>
                           </a:solidFill>
@@ -23102,7 +23102,7 @@
                         </a:rPr>
                         <a:t>Email / CRM</a:t>
                       </a:r>
-                      <a:endParaRPr lang="en-US" sz="1600" dirty="0">
+                      <a:endParaRPr lang="en-US" sz="1500" dirty="0">
                         <a:latin typeface="Helvetica Neue" charset="0"/>
                         <a:ea typeface="Helvetica Neue" charset="0"/>
                         <a:cs typeface="Helvetica Neue" charset="0"/>
@@ -23160,7 +23160,7 @@
                         <a:buNone/>
                       </a:pPr>
                       <a:r>
-                        <a:rPr lang="en-US" sz="1600" dirty="0">
+                        <a:rPr lang="en-US" sz="1500" dirty="0">
                           <a:solidFill>
                             <a:srgbClr val="EAEAEA"/>
                           </a:solidFill>
@@ -23170,7 +23170,7 @@
                         </a:rPr>
                         <a:t>18</a:t>
                       </a:r>
-                      <a:endParaRPr lang="en-US" sz="1600" dirty="0">
+                      <a:endParaRPr lang="en-US" sz="1500" dirty="0">
                         <a:latin typeface="Helvetica Neue" charset="0"/>
                         <a:ea typeface="Helvetica Neue" charset="0"/>
                         <a:cs typeface="Helvetica Neue" charset="0"/>
@@ -23228,7 +23228,7 @@
                         <a:buNone/>
                       </a:pPr>
                       <a:r>
-                        <a:rPr lang="en-US" sz="1600" dirty="0">
+                        <a:rPr lang="en-US" sz="1500" dirty="0">
                           <a:solidFill>
                             <a:srgbClr val="EAEAEA"/>
                           </a:solidFill>
@@ -23238,7 +23238,7 @@
                         </a:rPr>
                         <a:t>38</a:t>
                       </a:r>
-                      <a:endParaRPr lang="en-US" sz="1600" dirty="0">
+                      <a:endParaRPr lang="en-US" sz="1500" dirty="0">
                         <a:latin typeface="Helvetica Neue" charset="0"/>
                         <a:ea typeface="Helvetica Neue" charset="0"/>
                         <a:cs typeface="Helvetica Neue" charset="0"/>
@@ -23298,7 +23298,7 @@
                         <a:buNone/>
                       </a:pPr>
                       <a:r>
-                        <a:rPr lang="en-US" sz="1600" b="1" dirty="0">
+                        <a:rPr lang="en-US" sz="1500" b="1" dirty="0">
                           <a:solidFill>
                             <a:srgbClr val="EAEAEA"/>
                           </a:solidFill>
@@ -23308,7 +23308,7 @@
                         </a:rPr>
                         <a:t>Partners</a:t>
                       </a:r>
-                      <a:endParaRPr lang="en-US" sz="1600" dirty="0">
+                      <a:endParaRPr lang="en-US" sz="1500" dirty="0">
                         <a:latin typeface="Helvetica Neue" charset="0"/>
                         <a:ea typeface="Helvetica Neue" charset="0"/>
                         <a:cs typeface="Helvetica Neue" charset="0"/>
@@ -23366,7 +23366,7 @@
                         <a:buNone/>
                       </a:pPr>
                       <a:r>
-                        <a:rPr lang="en-US" sz="1600" dirty="0">
+                        <a:rPr lang="en-US" sz="1500" dirty="0">
                           <a:solidFill>
                             <a:srgbClr val="EAEAEA"/>
                           </a:solidFill>
@@ -23376,7 +23376,7 @@
                         </a:rPr>
                         <a:t>12</a:t>
                       </a:r>
-                      <a:endParaRPr lang="en-US" sz="1600" dirty="0">
+                      <a:endParaRPr lang="en-US" sz="1500" dirty="0">
                         <a:latin typeface="Helvetica Neue" charset="0"/>
                         <a:ea typeface="Helvetica Neue" charset="0"/>
                         <a:cs typeface="Helvetica Neue" charset="0"/>
@@ -23434,7 +23434,7 @@
                         <a:buNone/>
                       </a:pPr>
                       <a:r>
-                        <a:rPr lang="en-US" sz="1600" dirty="0">
+                        <a:rPr lang="en-US" sz="1500" dirty="0">
                           <a:solidFill>
                             <a:srgbClr val="EAEAEA"/>
                           </a:solidFill>
@@ -23444,7 +23444,7 @@
                         </a:rPr>
                         <a:t>29</a:t>
                       </a:r>
-                      <a:endParaRPr lang="en-US" sz="1600" dirty="0">
+                      <a:endParaRPr lang="en-US" sz="1500" dirty="0">
                         <a:latin typeface="Helvetica Neue" charset="0"/>
                         <a:ea typeface="Helvetica Neue" charset="0"/>
                         <a:cs typeface="Helvetica Neue" charset="0"/>
@@ -23504,7 +23504,7 @@
                         <a:buNone/>
                       </a:pPr>
                       <a:r>
-                        <a:rPr lang="en-US" sz="1600" b="1" dirty="0">
+                        <a:rPr lang="en-US" sz="1500" b="1" dirty="0">
                           <a:solidFill>
                             <a:srgbClr val="EAEAEA"/>
                           </a:solidFill>
@@ -23514,7 +23514,7 @@
                         </a:rPr>
                         <a:t>In-product</a:t>
                       </a:r>
-                      <a:endParaRPr lang="en-US" sz="1600" dirty="0">
+                      <a:endParaRPr lang="en-US" sz="1500" dirty="0">
                         <a:latin typeface="Helvetica Neue" charset="0"/>
                         <a:ea typeface="Helvetica Neue" charset="0"/>
                         <a:cs typeface="Helvetica Neue" charset="0"/>
@@ -23572,7 +23572,7 @@
                         <a:buNone/>
                       </a:pPr>
                       <a:r>
-                        <a:rPr lang="en-US" sz="1600" dirty="0">
+                        <a:rPr lang="en-US" sz="1500" dirty="0">
                           <a:solidFill>
                             <a:srgbClr val="EAEAEA"/>
                           </a:solidFill>
@@ -23582,7 +23582,7 @@
                         </a:rPr>
                         <a:t>8</a:t>
                       </a:r>
-                      <a:endParaRPr lang="en-US" sz="1600" dirty="0">
+                      <a:endParaRPr lang="en-US" sz="1500" dirty="0">
                         <a:latin typeface="Helvetica Neue" charset="0"/>
                         <a:ea typeface="Helvetica Neue" charset="0"/>
                         <a:cs typeface="Helvetica Neue" charset="0"/>
@@ -23640,7 +23640,7 @@
                         <a:buNone/>
                       </a:pPr>
                       <a:r>
-                        <a:rPr lang="en-US" sz="1600" dirty="0">
+                        <a:rPr lang="en-US" sz="1500" dirty="0">
                           <a:solidFill>
                             <a:srgbClr val="EAEAEA"/>
                           </a:solidFill>
@@ -23650,7 +23650,7 @@
                         </a:rPr>
                         <a:t>55</a:t>
                       </a:r>
-                      <a:endParaRPr lang="en-US" sz="1600" dirty="0">
+                      <a:endParaRPr lang="en-US" sz="1500" dirty="0">
                         <a:latin typeface="Helvetica Neue" charset="0"/>
                         <a:ea typeface="Helvetica Neue" charset="0"/>
                         <a:cs typeface="Helvetica Neue" charset="0"/>

</xml_diff>